<commit_message>
2a versao do Pitch
</commit_message>
<xml_diff>
--- a/PastaDocRequisitos/ApresentacaoPitch.pptx
+++ b/PastaDocRequisitos/ApresentacaoPitch.pptx
@@ -104,6 +104,11 @@
       </a:defRPr>
     </a:lvl9pPr>
   </p:defaultTextStyle>
+  <p:extLst>
+    <p:ext uri="{EFAFB233-063F-42B5-8137-9DF3F51BA10A}">
+      <p15:sldGuideLst xmlns:p15="http://schemas.microsoft.com/office/powerpoint/2012/main"/>
+    </p:ext>
+  </p:extLst>
 </p:presentation>
 </file>
 
@@ -3307,6 +3312,14 @@
 <file path=ppt/slides/slide1.xml><?xml version="1.0" encoding="utf-8"?>
 <p:sld xmlns:a="http://schemas.openxmlformats.org/drawingml/2006/main" xmlns:r="http://schemas.openxmlformats.org/officeDocument/2006/relationships" xmlns:p="http://schemas.openxmlformats.org/presentationml/2006/main">
   <p:cSld>
+    <p:bg>
+      <p:bgPr>
+        <a:solidFill>
+          <a:srgbClr val="FFC000"/>
+        </a:solidFill>
+        <a:effectLst/>
+      </p:bgPr>
+    </p:bg>
     <p:spTree>
       <p:nvGrpSpPr>
         <p:cNvPr id="1" name=""/>
@@ -3372,7 +3385,7 @@
           <a:p>
             <a:r>
               <a:rPr lang="pt-BR" dirty="0"/>
-              <a:t>Pitch preliminar</a:t>
+              <a:t>Pitch definitivo</a:t>
             </a:r>
           </a:p>
         </p:txBody>

</xml_diff>